<commit_message>
Update 신문지 서바이벌 assets and add ZIP slides
Co-Authored-By: Claude Opus 4.6 (1M context) <noreply@anthropic.com>
</commit_message>
<xml_diff>
--- a/public/downloads/games/newspaper-folding/rules.pptx
+++ b/public/downloads/games/newspaper-folding/rules.pptx
@@ -9,20 +9,17 @@
     <p:sldId id="257" r:id="rId7"/>
     <p:sldId id="258" r:id="rId8"/>
     <p:sldId id="259" r:id="rId9"/>
+    <p:sldId id="260" r:id="rId10"/>
   </p:sldIdLst>
   <p:sldSz cx="18288000" cy="10287000"/>
   <p:notesSz cx="6858000" cy="9144000"/>
   <p:embeddedFontLst>
     <p:embeddedFont>
-      <p:font typeface="Jua" charset="1" panose="00000000000000000000"/>
-      <p:regular r:id="rId10"/>
-    </p:embeddedFont>
-    <p:embeddedFont>
-      <p:font typeface="TDTD갬성명조" charset="1" panose="02000503000000000000"/>
+      <p:font typeface="무궁화 고딕" charset="1" panose="02020603020101020101"/>
       <p:regular r:id="rId11"/>
     </p:embeddedFont>
     <p:embeddedFont>
-      <p:font typeface="TDTD가온" charset="1" panose="02000503000000000000"/>
+      <p:font typeface="무궁화 고딕 Bold" charset="1" panose="02020603020101020101"/>
       <p:regular r:id="rId12"/>
     </p:embeddedFont>
   </p:embeddedFontLst>
@@ -3141,8 +3138,8 @@
         </p:nvSpPr>
         <p:spPr>
           <a:xfrm rot="0">
-            <a:off x="1028700" y="3892867"/>
-            <a:ext cx="15555091" cy="2200275"/>
+            <a:off x="1028700" y="4178617"/>
+            <a:ext cx="15555091" cy="1914525"/>
           </a:xfrm>
           <a:prstGeom prst="rect">
             <a:avLst/>
@@ -3164,10 +3161,10 @@
                 <a:solidFill>
                   <a:srgbClr val="FFFAEF"/>
                 </a:solidFill>
-                <a:latin typeface="Jua"/>
-                <a:ea typeface="Jua"/>
-                <a:cs typeface="Jua"/>
-                <a:sym typeface="Jua"/>
+                <a:latin typeface="무궁화 고딕"/>
+                <a:ea typeface="무궁화 고딕"/>
+                <a:cs typeface="무궁화 고딕"/>
+                <a:sym typeface="무궁화 고딕"/>
               </a:rPr>
               <a:t>신문지 서바이벌</a:t>
             </a:r>
@@ -3182,8 +3179,8 @@
         </p:nvSpPr>
         <p:spPr>
           <a:xfrm rot="0">
-            <a:off x="15264803" y="9812655"/>
-            <a:ext cx="2637975" cy="474345"/>
+            <a:off x="14583014" y="9822180"/>
+            <a:ext cx="3319765" cy="464820"/>
           </a:xfrm>
           <a:prstGeom prst="rect">
             <a:avLst/>
@@ -3208,10 +3205,10 @@
                 <a:solidFill>
                   <a:srgbClr val="FFFFFF"/>
                 </a:solidFill>
-                <a:latin typeface="TDTD갬성명조"/>
-                <a:ea typeface="TDTD갬성명조"/>
-                <a:cs typeface="TDTD갬성명조"/>
-                <a:sym typeface="TDTD갬성명조"/>
+                <a:latin typeface="무궁화 고딕"/>
+                <a:ea typeface="무궁화 고딕"/>
+                <a:cs typeface="무궁화 고딕"/>
+                <a:sym typeface="무궁화 고딕"/>
               </a:rPr>
               <a:t>ⓒ 2026. Sunday Play</a:t>
             </a:r>
@@ -3360,8 +3357,8 @@
         </p:nvSpPr>
         <p:spPr>
           <a:xfrm rot="0">
-            <a:off x="11392761" y="600705"/>
-            <a:ext cx="5362043" cy="1600200"/>
+            <a:off x="11392761" y="819780"/>
+            <a:ext cx="5362043" cy="1381125"/>
           </a:xfrm>
           <a:prstGeom prst="rect">
             <a:avLst/>
@@ -3383,10 +3380,10 @@
                 <a:solidFill>
                   <a:srgbClr val="FFFAEF"/>
                 </a:solidFill>
-                <a:latin typeface="Jua"/>
-                <a:ea typeface="Jua"/>
-                <a:cs typeface="Jua"/>
-                <a:sym typeface="Jua"/>
+                <a:latin typeface="무궁화 고딕"/>
+                <a:ea typeface="무궁화 고딕"/>
+                <a:cs typeface="무궁화 고딕"/>
+                <a:sym typeface="무궁화 고딕"/>
               </a:rPr>
               <a:t>규칙</a:t>
             </a:r>
@@ -3402,9 +3399,9 @@
         <p:grpSpPr>
           <a:xfrm rot="0">
             <a:off x="309172" y="535073"/>
-            <a:ext cx="9591749" cy="2942330"/>
+            <a:ext cx="9591749" cy="2601393"/>
             <a:chOff x="0" y="0"/>
-            <a:chExt cx="12788998" cy="3923107"/>
+            <a:chExt cx="12788998" cy="3468524"/>
           </a:xfrm>
         </p:grpSpPr>
         <p:sp>
@@ -3415,8 +3412,8 @@
           </p:nvSpPr>
           <p:spPr>
             <a:xfrm rot="0">
-              <a:off x="0" y="1625465"/>
-              <a:ext cx="12788998" cy="2297642"/>
+              <a:off x="0" y="1648191"/>
+              <a:ext cx="12788998" cy="1820333"/>
             </a:xfrm>
             <a:prstGeom prst="rect">
               <a:avLst/>
@@ -3430,37 +3427,37 @@
             <a:p>
               <a:pPr algn="l">
                 <a:lnSpc>
-                  <a:spcPts val="7000"/>
+                  <a:spcPts val="5599"/>
                 </a:lnSpc>
               </a:pPr>
               <a:r>
-                <a:rPr lang="en-US" sz="5000">
+                <a:rPr lang="en-US" sz="3999">
                   <a:solidFill>
                     <a:srgbClr val="FFFAEF"/>
                   </a:solidFill>
-                  <a:latin typeface="TDTD가온"/>
-                  <a:ea typeface="TDTD가온"/>
-                  <a:cs typeface="TDTD가온"/>
-                  <a:sym typeface="TDTD가온"/>
+                  <a:latin typeface="무궁화 고딕"/>
+                  <a:ea typeface="무궁화 고딕"/>
+                  <a:cs typeface="무궁화 고딕"/>
+                  <a:sym typeface="무궁화 고딕"/>
                 </a:rPr>
-                <a:t> 팀별로 신문지 1장 위에 전원이 올라가</a:t>
+                <a:t>팀별로 신문지 1장 위에 전원이 올라가</a:t>
               </a:r>
             </a:p>
             <a:p>
               <a:pPr algn="l">
                 <a:lnSpc>
-                  <a:spcPts val="7000"/>
+                  <a:spcPts val="5599"/>
                 </a:lnSpc>
               </a:pPr>
               <a:r>
-                <a:rPr lang="en-US" sz="5000">
+                <a:rPr lang="en-US" sz="3999">
                   <a:solidFill>
                     <a:srgbClr val="FFFAEF"/>
                   </a:solidFill>
-                  <a:latin typeface="TDTD가온"/>
-                  <a:ea typeface="TDTD가온"/>
-                  <a:cs typeface="TDTD가온"/>
-                  <a:sym typeface="TDTD가온"/>
+                  <a:latin typeface="무궁화 고딕"/>
+                  <a:ea typeface="무궁화 고딕"/>
+                  <a:cs typeface="무궁화 고딕"/>
+                  <a:sym typeface="무궁화 고딕"/>
                 </a:rPr>
                 <a:t>10초를 버티세요.</a:t>
               </a:r>
@@ -3475,8 +3472,8 @@
           </p:nvSpPr>
           <p:spPr>
             <a:xfrm rot="0">
-              <a:off x="0" y="-190500"/>
-              <a:ext cx="11298371" cy="1367863"/>
+              <a:off x="0" y="-66675"/>
+              <a:ext cx="11298371" cy="1238189"/>
             </a:xfrm>
             <a:prstGeom prst="rect">
               <a:avLst/>
@@ -3498,10 +3495,10 @@
                   <a:solidFill>
                     <a:srgbClr val="FFFAEF"/>
                   </a:solidFill>
-                  <a:latin typeface="Jua"/>
-                  <a:ea typeface="Jua"/>
-                  <a:cs typeface="Jua"/>
-                  <a:sym typeface="Jua"/>
+                  <a:latin typeface="무궁화 고딕 Bold"/>
+                  <a:ea typeface="무궁화 고딕 Bold"/>
+                  <a:cs typeface="무궁화 고딕 Bold"/>
+                  <a:sym typeface="무궁화 고딕 Bold"/>
                 </a:rPr>
                 <a:t>STEP 1.</a:t>
               </a:r>
@@ -3517,10 +3514,10 @@
         </p:nvGrpSpPr>
         <p:grpSpPr>
           <a:xfrm rot="0">
-            <a:off x="10161695" y="7950306"/>
-            <a:ext cx="7985937" cy="1994512"/>
+            <a:off x="10903642" y="8200435"/>
+            <a:ext cx="6957237" cy="1838937"/>
             <a:chOff x="0" y="0"/>
-            <a:chExt cx="10647916" cy="2659349"/>
+            <a:chExt cx="9276316" cy="2451916"/>
           </a:xfrm>
         </p:grpSpPr>
         <p:sp>
@@ -3531,8 +3528,8 @@
           </p:nvSpPr>
           <p:spPr>
             <a:xfrm rot="0">
-              <a:off x="0" y="1542808"/>
-              <a:ext cx="10546685" cy="1116541"/>
+              <a:off x="0" y="1571383"/>
+              <a:ext cx="9188125" cy="880533"/>
             </a:xfrm>
             <a:prstGeom prst="rect">
               <a:avLst/>
@@ -3546,18 +3543,18 @@
             <a:p>
               <a:pPr algn="l">
                 <a:lnSpc>
-                  <a:spcPts val="7000"/>
+                  <a:spcPts val="5599"/>
                 </a:lnSpc>
               </a:pPr>
               <a:r>
-                <a:rPr lang="en-US" sz="5000">
+                <a:rPr lang="en-US" sz="3999">
                   <a:solidFill>
                     <a:srgbClr val="FFFAEF"/>
                   </a:solidFill>
-                  <a:latin typeface="TDTD가온"/>
-                  <a:ea typeface="TDTD가온"/>
-                  <a:cs typeface="TDTD가온"/>
-                  <a:sym typeface="TDTD가온"/>
+                  <a:latin typeface="무궁화 고딕"/>
+                  <a:ea typeface="무궁화 고딕"/>
+                  <a:cs typeface="무궁화 고딕"/>
+                  <a:sym typeface="무궁화 고딕"/>
                 </a:rPr>
                 <a:t>가장 많이 접고도 버틴 팀이 우승!</a:t>
               </a:r>
@@ -3572,8 +3569,8 @@
           </p:nvSpPr>
           <p:spPr>
             <a:xfrm rot="0">
-              <a:off x="0" y="-190500"/>
-              <a:ext cx="10647916" cy="1374479"/>
+              <a:off x="0" y="-57150"/>
+              <a:ext cx="9276316" cy="1241129"/>
             </a:xfrm>
             <a:prstGeom prst="rect">
               <a:avLst/>
@@ -3595,10 +3592,10 @@
                   <a:solidFill>
                     <a:srgbClr val="FFFAEF"/>
                   </a:solidFill>
-                  <a:latin typeface="Jua"/>
-                  <a:ea typeface="Jua"/>
-                  <a:cs typeface="Jua"/>
-                  <a:sym typeface="Jua"/>
+                  <a:latin typeface="무궁화 고딕 Bold"/>
+                  <a:ea typeface="무궁화 고딕 Bold"/>
+                  <a:cs typeface="무궁화 고딕 Bold"/>
+                  <a:sym typeface="무궁화 고딕 Bold"/>
                 </a:rPr>
                 <a:t>STEP 3.</a:t>
               </a:r>
@@ -3614,10 +3611,10 @@
         </p:nvGrpSpPr>
         <p:grpSpPr>
           <a:xfrm rot="0">
-            <a:off x="4697442" y="3888583"/>
-            <a:ext cx="9376340" cy="2939517"/>
+            <a:off x="4837811" y="3902254"/>
+            <a:ext cx="9376340" cy="2596832"/>
             <a:chOff x="0" y="0"/>
-            <a:chExt cx="12501787" cy="3919356"/>
+            <a:chExt cx="12501787" cy="3462442"/>
           </a:xfrm>
         </p:grpSpPr>
         <p:sp>
@@ -3628,8 +3625,8 @@
           </p:nvSpPr>
           <p:spPr>
             <a:xfrm rot="0">
-              <a:off x="0" y="1631121"/>
-              <a:ext cx="12501787" cy="2288235"/>
+              <a:off x="0" y="1642109"/>
+              <a:ext cx="12501787" cy="1820333"/>
             </a:xfrm>
             <a:prstGeom prst="rect">
               <a:avLst/>
@@ -3643,18 +3640,18 @@
             <a:p>
               <a:pPr algn="l">
                 <a:lnSpc>
-                  <a:spcPts val="6995"/>
+                  <a:spcPts val="5599"/>
                 </a:lnSpc>
               </a:pPr>
               <a:r>
-                <a:rPr lang="en-US" sz="4996">
+                <a:rPr lang="en-US" sz="3999">
                   <a:solidFill>
                     <a:srgbClr val="FFFAEF"/>
                   </a:solidFill>
-                  <a:latin typeface="TDTD가온"/>
-                  <a:ea typeface="TDTD가온"/>
-                  <a:cs typeface="TDTD가온"/>
-                  <a:sym typeface="TDTD가온"/>
+                  <a:latin typeface="무궁화 고딕"/>
+                  <a:ea typeface="무궁화 고딕"/>
+                  <a:cs typeface="무궁화 고딕"/>
+                  <a:sym typeface="무궁화 고딕"/>
                 </a:rPr>
                 <a:t>통과하면 신문지를 반으로 접고 다시 도전!</a:t>
               </a:r>
@@ -3662,18 +3659,18 @@
             <a:p>
               <a:pPr algn="l">
                 <a:lnSpc>
-                  <a:spcPts val="6995"/>
+                  <a:spcPts val="5599"/>
                 </a:lnSpc>
               </a:pPr>
               <a:r>
-                <a:rPr lang="en-US" sz="4996">
+                <a:rPr lang="en-US" sz="3999">
                   <a:solidFill>
                     <a:srgbClr val="FFFAEF"/>
                   </a:solidFill>
-                  <a:latin typeface="TDTD가온"/>
-                  <a:ea typeface="TDTD가온"/>
-                  <a:cs typeface="TDTD가온"/>
-                  <a:sym typeface="TDTD가온"/>
+                  <a:latin typeface="무궁화 고딕"/>
+                  <a:ea typeface="무궁화 고딕"/>
+                  <a:cs typeface="무궁화 고딕"/>
+                  <a:sym typeface="무궁화 고딕"/>
                 </a:rPr>
                 <a:t>탈락하면 끝! </a:t>
               </a:r>
@@ -3688,8 +3685,8 @@
           </p:nvSpPr>
           <p:spPr>
             <a:xfrm rot="0">
-              <a:off x="0" y="-190500"/>
-              <a:ext cx="5178984" cy="1369906"/>
+              <a:off x="0" y="-66675"/>
+              <a:ext cx="5178984" cy="1238018"/>
             </a:xfrm>
             <a:prstGeom prst="rect">
               <a:avLst/>
@@ -3711,10 +3708,10 @@
                   <a:solidFill>
                     <a:srgbClr val="FFFAEF"/>
                   </a:solidFill>
-                  <a:latin typeface="Jua"/>
-                  <a:ea typeface="Jua"/>
-                  <a:cs typeface="Jua"/>
-                  <a:sym typeface="Jua"/>
+                  <a:latin typeface="무궁화 고딕 Bold"/>
+                  <a:ea typeface="무궁화 고딕 Bold"/>
+                  <a:cs typeface="무궁화 고딕 Bold"/>
+                  <a:sym typeface="무궁화 고딕 Bold"/>
                 </a:rPr>
                 <a:t>STEP 2.</a:t>
               </a:r>
@@ -3731,6 +3728,129 @@
 </file>
 
 <file path=ppt/slides/slide3.xml><?xml version="1.0" encoding="utf-8"?>
+<p:sld xmlns:p="http://schemas.openxmlformats.org/presentationml/2006/main" xmlns:a="http://schemas.openxmlformats.org/drawingml/2006/main" xmlns:r="http://schemas.openxmlformats.org/officeDocument/2006/relationships">
+  <p:cSld>
+    <p:bg>
+      <p:bgPr>
+        <a:solidFill>
+          <a:srgbClr val="FFFAEF"/>
+        </a:solidFill>
+      </p:bgPr>
+    </p:bg>
+    <p:spTree>
+      <p:nvGrpSpPr>
+        <p:cNvPr id="1" name=""/>
+        <p:cNvGrpSpPr/>
+        <p:nvPr/>
+      </p:nvGrpSpPr>
+      <p:grpSpPr>
+        <a:xfrm>
+          <a:off x="0" y="0"/>
+          <a:ext cx="0" cy="0"/>
+          <a:chOff x="0" y="0"/>
+          <a:chExt cx="0" cy="0"/>
+        </a:xfrm>
+      </p:grpSpPr>
+      <p:sp>
+        <p:nvSpPr>
+          <p:cNvPr name="TextBox 2" id="2"/>
+          <p:cNvSpPr txBox="true"/>
+          <p:nvPr/>
+        </p:nvSpPr>
+        <p:spPr>
+          <a:xfrm rot="0">
+            <a:off x="3238925" y="4378545"/>
+            <a:ext cx="11810151" cy="1914525"/>
+          </a:xfrm>
+          <a:prstGeom prst="rect">
+            <a:avLst/>
+          </a:prstGeom>
+        </p:spPr>
+        <p:txBody>
+          <a:bodyPr anchor="t" rtlCol="false" tIns="0" lIns="0" bIns="0" rIns="0">
+            <a:spAutoFit/>
+          </a:bodyPr>
+          <a:lstStyle/>
+          <a:p>
+            <a:pPr algn="ctr">
+              <a:lnSpc>
+                <a:spcPts val="15000"/>
+              </a:lnSpc>
+            </a:pPr>
+            <a:r>
+              <a:rPr lang="en-US" sz="12500">
+                <a:solidFill>
+                  <a:srgbClr val="000000"/>
+                </a:solidFill>
+                <a:latin typeface="무궁화 고딕"/>
+                <a:ea typeface="무궁화 고딕"/>
+                <a:cs typeface="무궁화 고딕"/>
+                <a:sym typeface="무궁화 고딕"/>
+              </a:rPr>
+              <a:t>팀을 나눠주세요!</a:t>
+            </a:r>
+          </a:p>
+        </p:txBody>
+      </p:sp>
+      <p:pic>
+        <p:nvPicPr>
+          <p:cNvPr name="Picture 3" id="3"/>
+          <p:cNvPicPr>
+            <a:picLocks noChangeAspect="true"/>
+          </p:cNvPicPr>
+          <p:nvPr/>
+        </p:nvPicPr>
+        <p:blipFill>
+          <a:blip r:embed="rId2"/>
+          <a:srcRect l="0" t="0" r="0" b="0"/>
+          <a:stretch>
+            <a:fillRect/>
+          </a:stretch>
+        </p:blipFill>
+        <p:spPr>
+          <a:xfrm flipH="false" flipV="false" rot="0">
+            <a:off x="13655377" y="6809666"/>
+            <a:ext cx="6229999" cy="6954669"/>
+          </a:xfrm>
+          <a:prstGeom prst="rect">
+            <a:avLst/>
+          </a:prstGeom>
+        </p:spPr>
+      </p:pic>
+      <p:pic>
+        <p:nvPicPr>
+          <p:cNvPr name="Picture 4" id="4"/>
+          <p:cNvPicPr>
+            <a:picLocks noChangeAspect="true"/>
+          </p:cNvPicPr>
+          <p:nvPr/>
+        </p:nvPicPr>
+        <p:blipFill>
+          <a:blip r:embed="rId3"/>
+          <a:srcRect l="0" t="0" r="0" b="0"/>
+          <a:stretch>
+            <a:fillRect/>
+          </a:stretch>
+        </p:blipFill>
+        <p:spPr>
+          <a:xfrm flipH="false" flipV="false" rot="0">
+            <a:off x="0" y="0"/>
+            <a:ext cx="6925457" cy="4700654"/>
+          </a:xfrm>
+          <a:prstGeom prst="rect">
+            <a:avLst/>
+          </a:prstGeom>
+        </p:spPr>
+      </p:pic>
+    </p:spTree>
+  </p:cSld>
+  <p:clrMapOvr>
+    <a:masterClrMapping/>
+  </p:clrMapOvr>
+</p:sld>
+</file>
+
+<file path=ppt/slides/slide4.xml><?xml version="1.0" encoding="utf-8"?>
 <p:sld xmlns:p="http://schemas.openxmlformats.org/presentationml/2006/main" xmlns:a="http://schemas.openxmlformats.org/drawingml/2006/main" xmlns:r="http://schemas.openxmlformats.org/officeDocument/2006/relationships">
   <p:cSld>
     <p:bg>
@@ -3812,8 +3932,8 @@
         </p:nvSpPr>
         <p:spPr>
           <a:xfrm rot="0">
-            <a:off x="1028700" y="3892867"/>
-            <a:ext cx="15555091" cy="2200275"/>
+            <a:off x="1028700" y="4178617"/>
+            <a:ext cx="15555091" cy="1914525"/>
           </a:xfrm>
           <a:prstGeom prst="rect">
             <a:avLst/>
@@ -3835,10 +3955,10 @@
                 <a:solidFill>
                   <a:srgbClr val="FFFAEF"/>
                 </a:solidFill>
-                <a:latin typeface="Jua"/>
-                <a:ea typeface="Jua"/>
-                <a:cs typeface="Jua"/>
-                <a:sym typeface="Jua"/>
+                <a:latin typeface="무궁화 고딕"/>
+                <a:ea typeface="무궁화 고딕"/>
+                <a:cs typeface="무궁화 고딕"/>
+                <a:sym typeface="무궁화 고딕"/>
               </a:rPr>
               <a:t>신문지 서바이벌</a:t>
             </a:r>
@@ -3853,8 +3973,8 @@
         </p:nvSpPr>
         <p:spPr>
           <a:xfrm rot="0">
-            <a:off x="15264803" y="9812655"/>
-            <a:ext cx="2637975" cy="474345"/>
+            <a:off x="14583014" y="9822180"/>
+            <a:ext cx="3319765" cy="464820"/>
           </a:xfrm>
           <a:prstGeom prst="rect">
             <a:avLst/>
@@ -3879,10 +3999,10 @@
                 <a:solidFill>
                   <a:srgbClr val="FFFFFF"/>
                 </a:solidFill>
-                <a:latin typeface="TDTD갬성명조"/>
-                <a:ea typeface="TDTD갬성명조"/>
-                <a:cs typeface="TDTD갬성명조"/>
-                <a:sym typeface="TDTD갬성명조"/>
+                <a:latin typeface="무궁화 고딕"/>
+                <a:ea typeface="무궁화 고딕"/>
+                <a:cs typeface="무궁화 고딕"/>
+                <a:sym typeface="무궁화 고딕"/>
               </a:rPr>
               <a:t>ⓒ 2026. Sunday Play</a:t>
             </a:r>
@@ -3897,7 +4017,7 @@
 </p:sld>
 </file>
 
-<file path=ppt/slides/slide4.xml><?xml version="1.0" encoding="utf-8"?>
+<file path=ppt/slides/slide5.xml><?xml version="1.0" encoding="utf-8"?>
 <p:sld xmlns:p="http://schemas.openxmlformats.org/presentationml/2006/main" xmlns:a="http://schemas.openxmlformats.org/drawingml/2006/main" xmlns:r="http://schemas.openxmlformats.org/officeDocument/2006/relationships">
   <p:cSld>
     <p:bg>
@@ -3954,8 +4074,8 @@
         </p:nvSpPr>
         <p:spPr>
           <a:xfrm rot="0">
-            <a:off x="4421807" y="3895725"/>
-            <a:ext cx="9444385" cy="2200275"/>
+            <a:off x="4421807" y="4181475"/>
+            <a:ext cx="9444385" cy="1914525"/>
           </a:xfrm>
           <a:prstGeom prst="rect">
             <a:avLst/>
@@ -3977,10 +4097,10 @@
                 <a:solidFill>
                   <a:srgbClr val="000000"/>
                 </a:solidFill>
-                <a:latin typeface="Jua"/>
-                <a:ea typeface="Jua"/>
-                <a:cs typeface="Jua"/>
-                <a:sym typeface="Jua"/>
+                <a:latin typeface="무궁화 고딕"/>
+                <a:ea typeface="무궁화 고딕"/>
+                <a:cs typeface="무궁화 고딕"/>
+                <a:sym typeface="무궁화 고딕"/>
               </a:rPr>
               <a:t>감사합니다!</a:t>
             </a:r>

</xml_diff>